<commit_message>
update readm et prez
</commit_message>
<xml_diff>
--- a/orford-live-presentation.pptx
+++ b/orford-live-presentation.pptx
@@ -5860,7 +5860,7 @@
                 <a:ea typeface="Trebuchet MS" pitchFamily="34" charset="-122"/>
                 <a:cs typeface="Trebuchet MS" pitchFamily="34" charset="-120"/>
               </a:rPr>
-              <a:t>Les 4 modules fonctionnels</a:t>
+              <a:t>Les 4 modules actuellement fonctionnels</a:t>
             </a:r>
             <a:endParaRPr lang="fr-CA" sz="3000" noProof="0" dirty="0"/>
           </a:p>
@@ -8434,27 +8434,6 @@
                 <a:cs typeface="Calibri" pitchFamily="34" charset="-120"/>
               </a:rPr>
               <a:t>Changer statuts &amp; données terrain</a:t>
-            </a:r>
-            <a:endParaRPr lang="fr-CA" sz="1200" noProof="0" dirty="0"/>
-          </a:p>
-          <a:p>
-            <a:pPr marL="342900" indent="-342900">
-              <a:spcAft>
-                <a:spcPts val="500"/>
-              </a:spcAft>
-              <a:buSzPct val="100000"/>
-              <a:buChar char="●"/>
-            </a:pPr>
-            <a:r>
-              <a:rPr lang="fr-CA" sz="1200" noProof="0" dirty="0">
-                <a:solidFill>
-                  <a:srgbClr val="64748B"/>
-                </a:solidFill>
-                <a:latin typeface="Calibri" pitchFamily="34" charset="0"/>
-                <a:ea typeface="Calibri" pitchFamily="34" charset="-122"/>
-                <a:cs typeface="Calibri" pitchFamily="34" charset="-120"/>
-              </a:rPr>
-              <a:t>Suppression de données interdite</a:t>
             </a:r>
             <a:endParaRPr lang="fr-CA" sz="1200" noProof="0" dirty="0"/>
           </a:p>

</xml_diff>